<commit_message>
Deck: headline zero-shot finding, measured tie rate, MuRIL wording
Slides 5 and 9 now lead with the measured English-to-Indic collapse (macro-F1
0.341, None predicted for 131/150) paired with the 58.9% vocabulary overlap,
caveated as a synthetic development pilot. Slides 3 and 6 use 215/2,300 = 9.3%.

Co-Authored-By: Claude Sonnet 5.5 <noreply@anthropic.com>
</commit_message>
<xml_diff>
--- a/outputs/Milestone1_Sumukh_S24CSEU0570.pptx
+++ b/outputs/Milestone1_Sumukh_S24CSEU0570.pptx
@@ -861,7 +861,7 @@
           <a:lstStyle/>
           <a:p>
             <a:r>
-              <a:t>The gap table is in data/DATASET_INVENTORY.md. The shared-task property: English train, Hindi/Bengali test.</a:t>
+              <a:t>Headline measured result: English-trained TF-IDF on the Indic pilot gives macro-F1 0.341 and predicts None for 131/150. Gap table: data/DATASET_INVENTORY.md. Pilot is synthetic, development only.</a:t>
             </a:r>
           </a:p>
         </p:txBody>
@@ -1141,7 +1141,7 @@
           <a:lstStyle/>
           <a:p>
             <a:r>
-              <a:t>English CV numbers are optimistic (no document ids, one hashtag cluster). Pilot numbers are development only.</a:t>
+              <a:t>Headline: English-to-Indic zero-shot collapses to majority-class prediction (pilot: synthetic, dev only). English CV numbers are optimistic (no document ids, one hashtag cluster).</a:t>
             </a:r>
           </a:p>
         </p:txBody>
@@ -7236,7 +7236,7 @@
                 <a:latin typeface="Calibri"/>
                 <a:cs typeface="Nirmala UI"/>
               </a:rPr>
-              <a:t>Neutral + off-topic + ambiguous. 202 of 2,047 annotated sentences (9.9%) had no annotator majority.</a:t>
+              <a:t>Neutral + off-topic + ambiguous. 215 of 2,300 annotated sentences (9.3%) had no annotator majority.</a:t>
             </a:r>
           </a:p>
         </p:txBody>
@@ -8684,7 +8684,7 @@
         <p:spPr>
           <a:xfrm>
             <a:off x="502920" y="1417320"/>
-            <a:ext cx="3291840" cy="914400"/>
+            <a:ext cx="3291840" cy="822960"/>
           </a:xfrm>
           <a:prstGeom prst="rect">
             <a:avLst/>
@@ -8741,8 +8741,8 @@
         </p:nvSpPr>
         <p:spPr>
           <a:xfrm>
-            <a:off x="502920" y="2468880"/>
-            <a:ext cx="3291840" cy="822960"/>
+            <a:off x="502920" y="2286000"/>
+            <a:ext cx="3291840" cy="548640"/>
           </a:xfrm>
           <a:prstGeom prst="rect">
             <a:avLst/>
@@ -8777,7 +8777,7 @@
               </a:spcAft>
             </a:pPr>
             <a:r>
-              <a:rPr sz="1700" b="0" i="0">
+              <a:rPr sz="1600" b="0" i="0">
                 <a:solidFill>
                   <a:srgbClr val="5C677D"/>
                 </a:solidFill>
@@ -8797,7 +8797,7 @@
         </p:nvSpPr>
         <p:spPr>
           <a:xfrm>
-            <a:off x="1600200" y="3246120"/>
+            <a:off x="1600200" y="2788920"/>
             <a:ext cx="1097280" cy="685800"/>
           </a:xfrm>
           <a:prstGeom prst="rect">
@@ -8853,8 +8853,8 @@
         </p:nvSpPr>
         <p:spPr>
           <a:xfrm>
-            <a:off x="502920" y="3931920"/>
-            <a:ext cx="3291840" cy="914400"/>
+            <a:off x="502920" y="3520440"/>
+            <a:ext cx="3291840" cy="822960"/>
           </a:xfrm>
           <a:prstGeom prst="rect">
             <a:avLst/>
@@ -8911,8 +8911,8 @@
         </p:nvSpPr>
         <p:spPr>
           <a:xfrm>
-            <a:off x="502920" y="4937760"/>
-            <a:ext cx="3291840" cy="1097280"/>
+            <a:off x="502920" y="4389120"/>
+            <a:ext cx="3291840" cy="822960"/>
           </a:xfrm>
           <a:prstGeom prst="rect">
             <a:avLst/>
@@ -8947,14 +8947,14 @@
               </a:spcAft>
             </a:pPr>
             <a:r>
-              <a:rPr sz="1500" b="0" i="0">
+              <a:rPr sz="1400" b="0" i="0">
                 <a:solidFill>
                   <a:srgbClr val="5C677D"/>
                 </a:solidFill>
                 <a:latin typeface="Calibri"/>
                 <a:cs typeface="Nirmala UI"/>
               </a:rPr>
-              <a:t>hidden test set: code-mixing, spelling variation, negation, implicit stance</a:t>
+              <a:t>hidden test: code-mixing, spelling variation, negation, implicit stance</a:t>
             </a:r>
           </a:p>
         </p:txBody>
@@ -8969,7 +8969,7 @@
         </p:nvGraphicFramePr>
         <p:xfrm>
           <a:off x="4206240" y="1417320"/>
-          <a:ext cx="7452360" cy="3852664"/>
+          <a:ext cx="7452360" cy="3006852"/>
         </p:xfrm>
         <a:graphic>
           <a:graphicData uri="http://schemas.openxmlformats.org/drawingml/2006/table">
@@ -8983,14 +8983,14 @@
                 <a:gridCol w="1656080"/>
                 <a:gridCol w="1821688"/>
               </a:tblGrid>
-              <a:tr h="605535">
+              <a:tr h="347472">
                 <a:tc>
                   <a:txBody>
                     <a:bodyPr wrap="square"/>
                     <a:lstStyle/>
                     <a:p>
                       <a:r>
-                        <a:rPr sz="1600" b="1" i="0">
+                        <a:rPr sz="1500" b="1" i="0">
                           <a:solidFill>
                             <a:srgbClr val="FFFFFF"/>
                           </a:solidFill>
@@ -9013,7 +9013,7 @@
                     <a:lstStyle/>
                     <a:p>
                       <a:r>
-                        <a:rPr sz="1600" b="1" i="0">
+                        <a:rPr sz="1500" b="1" i="0">
                           <a:solidFill>
                             <a:srgbClr val="FFFFFF"/>
                           </a:solidFill>
@@ -9036,7 +9036,7 @@
                     <a:lstStyle/>
                     <a:p>
                       <a:r>
-                        <a:rPr sz="1600" b="1" i="0">
+                        <a:rPr sz="1500" b="1" i="0">
                           <a:solidFill>
                             <a:srgbClr val="FFFFFF"/>
                           </a:solidFill>
@@ -9059,7 +9059,7 @@
                     <a:lstStyle/>
                     <a:p>
                       <a:r>
-                        <a:rPr sz="1600" b="1" i="0">
+                        <a:rPr sz="1500" b="1" i="0">
                           <a:solidFill>
                             <a:srgbClr val="FFFFFF"/>
                           </a:solidFill>
@@ -9077,14 +9077,14 @@
                   </a:tcPr>
                 </a:tc>
               </a:tr>
-              <a:tr h="605535">
+              <a:tr h="347472">
                 <a:tc>
                   <a:txBody>
                     <a:bodyPr wrap="square"/>
                     <a:lstStyle/>
                     <a:p>
                       <a:r>
-                        <a:rPr sz="1600" b="1" i="0">
+                        <a:rPr sz="1500" b="1" i="0">
                           <a:solidFill>
                             <a:srgbClr val="1B263B"/>
                           </a:solidFill>
@@ -9107,7 +9107,7 @@
                     <a:lstStyle/>
                     <a:p>
                       <a:r>
-                        <a:rPr sz="1600" b="0" i="0">
+                        <a:rPr sz="1500" b="0" i="0">
                           <a:solidFill>
                             <a:srgbClr val="1B263B"/>
                           </a:solidFill>
@@ -9130,7 +9130,7 @@
                     <a:lstStyle/>
                     <a:p>
                       <a:r>
-                        <a:rPr sz="1600" b="0" i="0">
+                        <a:rPr sz="1500" b="0" i="0">
                           <a:solidFill>
                             <a:srgbClr val="1B263B"/>
                           </a:solidFill>
@@ -9153,7 +9153,7 @@
                     <a:lstStyle/>
                     <a:p>
                       <a:r>
-                        <a:rPr sz="1600" b="0" i="0">
+                        <a:rPr sz="1500" b="0" i="0">
                           <a:solidFill>
                             <a:srgbClr val="1B263B"/>
                           </a:solidFill>
@@ -9171,14 +9171,14 @@
                   </a:tcPr>
                 </a:tc>
               </a:tr>
-              <a:tr h="357631">
+              <a:tr h="347472">
                 <a:tc>
                   <a:txBody>
                     <a:bodyPr wrap="square"/>
                     <a:lstStyle/>
                     <a:p>
                       <a:r>
-                        <a:rPr sz="1600" b="1" i="0">
+                        <a:rPr sz="1500" b="1" i="0">
                           <a:solidFill>
                             <a:srgbClr val="1B263B"/>
                           </a:solidFill>
@@ -9201,7 +9201,7 @@
                     <a:lstStyle/>
                     <a:p>
                       <a:r>
-                        <a:rPr sz="1600" b="0" i="0">
+                        <a:rPr sz="1500" b="0" i="0">
                           <a:solidFill>
                             <a:srgbClr val="1B263B"/>
                           </a:solidFill>
@@ -9224,7 +9224,7 @@
                     <a:lstStyle/>
                     <a:p>
                       <a:r>
-                        <a:rPr sz="1600" b="0" i="0">
+                        <a:rPr sz="1500" b="0" i="0">
                           <a:solidFill>
                             <a:srgbClr val="1B263B"/>
                           </a:solidFill>
@@ -9247,7 +9247,7 @@
                     <a:lstStyle/>
                     <a:p>
                       <a:r>
-                        <a:rPr sz="1600" b="0" i="0">
+                        <a:rPr sz="1500" b="0" i="0">
                           <a:solidFill>
                             <a:srgbClr val="1B263B"/>
                           </a:solidFill>
@@ -9265,14 +9265,14 @@
                   </a:tcPr>
                 </a:tc>
               </a:tr>
-              <a:tr h="357631">
+              <a:tr h="347472">
                 <a:tc>
                   <a:txBody>
                     <a:bodyPr wrap="square"/>
                     <a:lstStyle/>
                     <a:p>
                       <a:r>
-                        <a:rPr sz="1600" b="1" i="0">
+                        <a:rPr sz="1500" b="1" i="0">
                           <a:solidFill>
                             <a:srgbClr val="1B263B"/>
                           </a:solidFill>
@@ -9295,7 +9295,7 @@
                     <a:lstStyle/>
                     <a:p>
                       <a:r>
-                        <a:rPr sz="1600" b="0" i="0">
+                        <a:rPr sz="1500" b="0" i="0">
                           <a:solidFill>
                             <a:srgbClr val="1B263B"/>
                           </a:solidFill>
@@ -9318,7 +9318,7 @@
                     <a:lstStyle/>
                     <a:p>
                       <a:r>
-                        <a:rPr sz="1600" b="0" i="0">
+                        <a:rPr sz="1500" b="0" i="0">
                           <a:solidFill>
                             <a:srgbClr val="1B263B"/>
                           </a:solidFill>
@@ -9341,7 +9341,7 @@
                     <a:lstStyle/>
                     <a:p>
                       <a:r>
-                        <a:rPr sz="1600" b="0" i="0">
+                        <a:rPr sz="1500" b="0" i="0">
                           <a:solidFill>
                             <a:srgbClr val="1B263B"/>
                           </a:solidFill>
@@ -9359,14 +9359,14 @@
                   </a:tcPr>
                 </a:tc>
               </a:tr>
-              <a:tr h="357631">
+              <a:tr h="347472">
                 <a:tc>
                   <a:txBody>
                     <a:bodyPr wrap="square"/>
                     <a:lstStyle/>
                     <a:p>
                       <a:r>
-                        <a:rPr sz="1600" b="1" i="0">
+                        <a:rPr sz="1500" b="1" i="0">
                           <a:solidFill>
                             <a:srgbClr val="1B263B"/>
                           </a:solidFill>
@@ -9389,7 +9389,7 @@
                     <a:lstStyle/>
                     <a:p>
                       <a:r>
-                        <a:rPr sz="1600" b="0" i="0">
+                        <a:rPr sz="1500" b="0" i="0">
                           <a:solidFill>
                             <a:srgbClr val="1B263B"/>
                           </a:solidFill>
@@ -9412,7 +9412,7 @@
                     <a:lstStyle/>
                     <a:p>
                       <a:r>
-                        <a:rPr sz="1600" b="0" i="0">
+                        <a:rPr sz="1500" b="0" i="0">
                           <a:solidFill>
                             <a:srgbClr val="1B263B"/>
                           </a:solidFill>
@@ -9435,7 +9435,7 @@
                     <a:lstStyle/>
                     <a:p>
                       <a:r>
-                        <a:rPr sz="1600" b="0" i="0">
+                        <a:rPr sz="1500" b="0" i="0">
                           <a:solidFill>
                             <a:srgbClr val="1B263B"/>
                           </a:solidFill>
@@ -9453,14 +9453,14 @@
                   </a:tcPr>
                 </a:tc>
               </a:tr>
-              <a:tr h="357631">
+              <a:tr h="347472">
                 <a:tc>
                   <a:txBody>
                     <a:bodyPr wrap="square"/>
                     <a:lstStyle/>
                     <a:p>
                       <a:r>
-                        <a:rPr sz="1600" b="1" i="0">
+                        <a:rPr sz="1500" b="1" i="0">
                           <a:solidFill>
                             <a:srgbClr val="1B263B"/>
                           </a:solidFill>
@@ -9483,7 +9483,7 @@
                     <a:lstStyle/>
                     <a:p>
                       <a:r>
-                        <a:rPr sz="1600" b="0" i="0">
+                        <a:rPr sz="1500" b="0" i="0">
                           <a:solidFill>
                             <a:srgbClr val="1B263B"/>
                           </a:solidFill>
@@ -9506,7 +9506,7 @@
                     <a:lstStyle/>
                     <a:p>
                       <a:r>
-                        <a:rPr sz="1600" b="0" i="0">
+                        <a:rPr sz="1500" b="0" i="0">
                           <a:solidFill>
                             <a:srgbClr val="1B263B"/>
                           </a:solidFill>
@@ -9529,7 +9529,7 @@
                     <a:lstStyle/>
                     <a:p>
                       <a:r>
-                        <a:rPr sz="1600" b="0" i="0">
+                        <a:rPr sz="1500" b="0" i="0">
                           <a:solidFill>
                             <a:srgbClr val="1B263B"/>
                           </a:solidFill>
@@ -9547,14 +9547,14 @@
                   </a:tcPr>
                 </a:tc>
               </a:tr>
-              <a:tr h="605535">
+              <a:tr h="574548">
                 <a:tc>
                   <a:txBody>
                     <a:bodyPr wrap="square"/>
                     <a:lstStyle/>
                     <a:p>
                       <a:r>
-                        <a:rPr sz="1600" b="1" i="0">
+                        <a:rPr sz="1500" b="1" i="0">
                           <a:solidFill>
                             <a:srgbClr val="1B263B"/>
                           </a:solidFill>
@@ -9577,7 +9577,7 @@
                     <a:lstStyle/>
                     <a:p>
                       <a:r>
-                        <a:rPr sz="1600" b="0" i="0">
+                        <a:rPr sz="1500" b="0" i="0">
                           <a:solidFill>
                             <a:srgbClr val="1B263B"/>
                           </a:solidFill>
@@ -9600,7 +9600,7 @@
                     <a:lstStyle/>
                     <a:p>
                       <a:r>
-                        <a:rPr sz="1600" b="0" i="0">
+                        <a:rPr sz="1500" b="0" i="0">
                           <a:solidFill>
                             <a:srgbClr val="1B263B"/>
                           </a:solidFill>
@@ -9623,7 +9623,7 @@
                     <a:lstStyle/>
                     <a:p>
                       <a:r>
-                        <a:rPr sz="1600" b="0" i="0">
+                        <a:rPr sz="1500" b="0" i="0">
                           <a:solidFill>
                             <a:srgbClr val="1B263B"/>
                           </a:solidFill>
@@ -9641,14 +9641,14 @@
                   </a:tcPr>
                 </a:tc>
               </a:tr>
-              <a:tr h="605535">
+              <a:tr h="347472">
                 <a:tc>
                   <a:txBody>
                     <a:bodyPr wrap="square"/>
                     <a:lstStyle/>
                     <a:p>
                       <a:r>
-                        <a:rPr sz="1600" b="1" i="0">
+                        <a:rPr sz="1500" b="1" i="0">
                           <a:solidFill>
                             <a:srgbClr val="1B263B"/>
                           </a:solidFill>
@@ -9671,7 +9671,7 @@
                     <a:lstStyle/>
                     <a:p>
                       <a:r>
-                        <a:rPr sz="1600" b="0" i="0">
+                        <a:rPr sz="1500" b="0" i="0">
                           <a:solidFill>
                             <a:srgbClr val="1B263B"/>
                           </a:solidFill>
@@ -9694,7 +9694,7 @@
                     <a:lstStyle/>
                     <a:p>
                       <a:r>
-                        <a:rPr sz="1600" b="0" i="0">
+                        <a:rPr sz="1500" b="0" i="0">
                           <a:solidFill>
                             <a:srgbClr val="1B263B"/>
                           </a:solidFill>
@@ -9717,7 +9717,7 @@
                     <a:lstStyle/>
                     <a:p>
                       <a:r>
-                        <a:rPr sz="1600" b="0" i="0">
+                        <a:rPr sz="1500" b="0" i="0">
                           <a:solidFill>
                             <a:srgbClr val="1B263B"/>
                           </a:solidFill>
@@ -9747,15 +9747,19 @@
         </p:nvSpPr>
         <p:spPr>
           <a:xfrm>
-            <a:off x="4206240" y="5669280"/>
-            <a:ext cx="7452360" cy="640080"/>
+            <a:off x="502920" y="5349240"/>
+            <a:ext cx="11155680" cy="1005840"/>
           </a:xfrm>
           <a:prstGeom prst="rect">
             <a:avLst/>
           </a:prstGeom>
-          <a:noFill/>
-          <a:ln>
-            <a:noFill/>
+          <a:solidFill>
+            <a:srgbClr val="FDECE8"/>
+          </a:solidFill>
+          <a:ln w="19050">
+            <a:solidFill>
+              <a:srgbClr val="E76F51"/>
+            </a:solidFill>
           </a:ln>
           <a:effectLst/>
         </p:spPr>
@@ -9774,7 +9778,7 @@
           </a:fontRef>
         </p:style>
         <p:txBody>
-          <a:bodyPr rtlCol="0" anchor="t" wrap="square" lIns="0" rIns="0"/>
+          <a:bodyPr rtlCol="0" anchor="ctr" wrap="square" lIns="137160" rIns="137160"/>
           <a:lstStyle/>
           <a:p>
             <a:pPr algn="l">
@@ -9783,14 +9787,34 @@
               </a:spcAft>
             </a:pPr>
             <a:r>
-              <a:rPr sz="1700" b="1" i="0">
-                <a:solidFill>
-                  <a:srgbClr val="1F2A44"/>
-                </a:solidFill>
-                <a:latin typeface="Calibri"/>
-                <a:cs typeface="Nirmala UI"/>
-              </a:rPr>
-              <a:t>Cross-lingual transfer problem: target-correct labels are English, evaluation is Indic.</a:t>
+              <a:rPr sz="1500" b="1" i="0">
+                <a:solidFill>
+                  <a:srgbClr val="E76F51"/>
+                </a:solidFill>
+                <a:latin typeface="Calibri"/>
+                <a:cs typeface="Nirmala UI"/>
+              </a:rPr>
+              <a:t>Measured, not assumed: </a:t>
+            </a:r>
+            <a:r>
+              <a:rPr sz="1500" b="0" i="0">
+                <a:solidFill>
+                  <a:srgbClr val="1B263B"/>
+                </a:solidFill>
+                <a:latin typeface="Calibri"/>
+                <a:cs typeface="Nirmala UI"/>
+              </a:rPr>
+              <a:t>English-trained TF-IDF on the Indic pilot reaches macro-F1 0.341 (floor 0.167) and predicts None for 131 of 150: cross-lingual transfer collapses to majority-class prediction, so in-language data and Indic-specific models are needed. 58.9% of Against vocabulary also appears in Favour: not simple text classification. </a:t>
+            </a:r>
+            <a:r>
+              <a:rPr sz="1500" b="0" i="1">
+                <a:solidFill>
+                  <a:srgbClr val="5C677D"/>
+                </a:solidFill>
+                <a:latin typeface="Calibri"/>
+                <a:cs typeface="Nirmala UI"/>
+              </a:rPr>
+              <a:t>(Pilot: synthetic, development only.)</a:t>
             </a:r>
           </a:p>
         </p:txBody>
@@ -10278,7 +10302,7 @@
                 <a:latin typeface="Calibri"/>
                 <a:cs typeface="Nirmala UI"/>
               </a:rPr>
-              <a:t>Ties dropped: </a:t>
+              <a:t>No annotator majority: </a:t>
             </a:r>
             <a:r>
               <a:rPr sz="1800" b="0" i="0">
@@ -10288,7 +10312,7 @@
                 <a:latin typeface="Calibri"/>
                 <a:cs typeface="Nirmala UI"/>
               </a:rPr>
-              <a:t>202 (9.9% of GWSD)</a:t>
+              <a:t>215 of 2,300 GWSD (9.3%); 202 remain after dedup, dropped</a:t>
             </a:r>
           </a:p>
           <a:p>
@@ -12334,7 +12358,7 @@
                 <a:latin typeface="Calibri"/>
                 <a:cs typeface="Nirmala UI"/>
               </a:rPr>
-              <a:t>IndicXNLI: MuRIL beats XLM-R, mBERT and IndicBERT on Indic languages; English + Indic training is best. Indic words stay whole.</a:t>
+              <a:t>IndicXNLI: MuRIL beats XLM-R, mBERT and IndicBERT on Indic languages; English + Indic training is best. Pretrained with transliterated text.</a:t>
             </a:r>
           </a:p>
         </p:txBody>
@@ -12829,8 +12853,8 @@
         </p:blipFill>
         <p:spPr>
           <a:xfrm>
-            <a:off x="411480" y="1371600"/>
-            <a:ext cx="6126480" cy="3315506"/>
+            <a:off x="411480" y="1325880"/>
+            <a:ext cx="5394960" cy="2919625"/>
           </a:xfrm>
           <a:prstGeom prst="rect">
             <a:avLst/>
@@ -12853,8 +12877,8 @@
         </p:blipFill>
         <p:spPr>
           <a:xfrm>
-            <a:off x="6903720" y="1371600"/>
-            <a:ext cx="3429000" cy="3033346"/>
+            <a:off x="5943600" y="1325880"/>
+            <a:ext cx="2926080" cy="2588455"/>
           </a:xfrm>
           <a:prstGeom prst="rect">
             <a:avLst/>
@@ -12869,8 +12893,8 @@
         </p:nvSpPr>
         <p:spPr>
           <a:xfrm>
-            <a:off x="10378440" y="1417320"/>
-            <a:ext cx="1463040" cy="2926080"/>
+            <a:off x="9052560" y="1463040"/>
+            <a:ext cx="2743200" cy="2194560"/>
           </a:xfrm>
           <a:prstGeom prst="rect">
             <a:avLst/>
@@ -12905,14 +12929,14 @@
               </a:spcAft>
             </a:pPr>
             <a:r>
-              <a:rPr sz="1500" b="1" i="0">
+              <a:rPr sz="1700" b="1" i="0">
                 <a:solidFill>
                   <a:srgbClr val="1F2A44"/>
                 </a:solidFill>
                 <a:latin typeface="Calibri"/>
                 <a:cs typeface="Nirmala UI"/>
               </a:rPr>
-              <a:t>Best: word+char LogReg</a:t>
+              <a:t>Best (English CV):</a:t>
             </a:r>
           </a:p>
           <a:p>
@@ -12922,13 +12946,30 @@
               </a:spcAft>
             </a:pPr>
             <a:r>
-              <a:rPr sz="1500" b="1" i="0">
+              <a:rPr sz="1700" b="1" i="0">
                 <a:solidFill>
                   <a:srgbClr val="1F2A44"/>
                 </a:solidFill>
                 <a:latin typeface="Calibri"/>
                 <a:cs typeface="Nirmala UI"/>
               </a:rPr>
+              <a:t>word+char LogReg</a:t>
+            </a:r>
+          </a:p>
+          <a:p>
+            <a:pPr algn="l">
+              <a:spcAft>
+                <a:spcPts val="400"/>
+              </a:spcAft>
+            </a:pPr>
+            <a:r>
+              <a:rPr sz="1700" b="1" i="0">
+                <a:solidFill>
+                  <a:srgbClr val="1F2A44"/>
+                </a:solidFill>
+                <a:latin typeface="Calibri"/>
+                <a:cs typeface="Nirmala UI"/>
+              </a:rPr>
               <a:t>macro-F1 0.613</a:t>
             </a:r>
           </a:p>
@@ -12939,7 +12980,7 @@
               </a:spcAft>
             </a:pPr>
             <a:r>
-              <a:rPr sz="1500" b="1" i="0">
+              <a:rPr sz="1700" b="1" i="0">
                 <a:solidFill>
                   <a:srgbClr val="1F2A44"/>
                 </a:solidFill>
@@ -12959,8 +13000,88 @@
         </p:nvSpPr>
         <p:spPr>
           <a:xfrm>
-            <a:off x="502920" y="4617720"/>
-            <a:ext cx="11155680" cy="1737360"/>
+            <a:off x="502920" y="4389120"/>
+            <a:ext cx="11155680" cy="1188720"/>
+          </a:xfrm>
+          <a:prstGeom prst="rect">
+            <a:avLst/>
+          </a:prstGeom>
+          <a:solidFill>
+            <a:srgbClr val="FDECE8"/>
+          </a:solidFill>
+          <a:ln w="19050">
+            <a:solidFill>
+              <a:srgbClr val="E76F51"/>
+            </a:solidFill>
+          </a:ln>
+          <a:effectLst/>
+        </p:spPr>
+        <p:style>
+          <a:lnRef idx="1">
+            <a:schemeClr val="accent1"/>
+          </a:lnRef>
+          <a:fillRef idx="3">
+            <a:schemeClr val="accent1"/>
+          </a:fillRef>
+          <a:effectRef idx="2">
+            <a:schemeClr val="accent1"/>
+          </a:effectRef>
+          <a:fontRef idx="minor">
+            <a:schemeClr val="lt1"/>
+          </a:fontRef>
+        </p:style>
+        <p:txBody>
+          <a:bodyPr rtlCol="0" anchor="ctr" wrap="square" lIns="137160" rIns="137160"/>
+          <a:lstStyle/>
+          <a:p>
+            <a:pPr algn="l">
+              <a:spcAft>
+                <a:spcPts val="400"/>
+              </a:spcAft>
+            </a:pPr>
+            <a:r>
+              <a:rPr sz="1700" b="1" i="0">
+                <a:solidFill>
+                  <a:srgbClr val="E76F51"/>
+                </a:solidFill>
+                <a:latin typeface="Calibri"/>
+                <a:cs typeface="Nirmala UI"/>
+              </a:rPr>
+              <a:t>Headline finding: </a:t>
+            </a:r>
+            <a:r>
+              <a:rPr sz="1700" b="0" i="0">
+                <a:solidFill>
+                  <a:srgbClr val="1B263B"/>
+                </a:solidFill>
+                <a:latin typeface="Calibri"/>
+                <a:cs typeface="Nirmala UI"/>
+              </a:rPr>
+              <a:t>English to Indic zero-shot collapses: macro-F1 0.341 vs floor 0.167, predicting None for 131 of 150 comments. With 58.9% of Against vocabulary also in Favour, this is not simple text classification. </a:t>
+            </a:r>
+            <a:r>
+              <a:rPr sz="1700" b="0" i="1">
+                <a:solidFill>
+                  <a:srgbClr val="5C677D"/>
+                </a:solidFill>
+                <a:latin typeface="Calibri"/>
+                <a:cs typeface="Nirmala UI"/>
+              </a:rPr>
+              <a:t>(Pilot: synthetic, dev only; not comparable to official results.)</a:t>
+            </a:r>
+          </a:p>
+        </p:txBody>
+      </p:sp>
+      <p:sp>
+        <p:nvSpPr>
+          <p:cNvPr id="10" name="Rectangle 9"/>
+          <p:cNvSpPr/>
+          <p:nvPr/>
+        </p:nvSpPr>
+        <p:spPr>
+          <a:xfrm>
+            <a:off x="502920" y="5669280"/>
+            <a:ext cx="11155680" cy="731520"/>
           </a:xfrm>
           <a:prstGeom prst="rect">
             <a:avLst/>
@@ -12991,11 +13112,11 @@
           <a:p>
             <a:pPr algn="l">
               <a:spcAft>
-                <a:spcPts val="500"/>
-              </a:spcAft>
-            </a:pPr>
-            <a:r>
-              <a:rPr sz="1600" b="1" i="0">
+                <a:spcPts val="200"/>
+              </a:spcAft>
+            </a:pPr>
+            <a:r>
+              <a:rPr sz="1400" b="1" i="0">
                 <a:solidFill>
                   <a:srgbClr val="1B263B"/>
                 </a:solidFill>
@@ -13005,24 +13126,24 @@
               <a:t>Runs today: </a:t>
             </a:r>
             <a:r>
-              <a:rPr sz="1600" b="0" i="0">
+              <a:rPr sz="1400" b="0" i="0">
                 <a:solidFill>
                   <a:srgbClr val="1B263B"/>
                 </a:solidFill>
                 <a:latin typeface="Calibri"/>
                 <a:cs typeface="Nirmala UI"/>
               </a:rPr>
-              <a:t>loader + validation gate, preprocessing, EDA, TF-IDF baselines, self-checks</a:t>
+              <a:t>loader + validation gate, preprocessing, EDA, TF-IDF baselines, self-checks.</a:t>
             </a:r>
           </a:p>
           <a:p>
             <a:pPr algn="l">
               <a:spcAft>
-                <a:spcPts val="500"/>
-              </a:spcAft>
-            </a:pPr>
-            <a:r>
-              <a:rPr sz="1600" b="1" i="0">
+                <a:spcPts val="200"/>
+              </a:spcAft>
+            </a:pPr>
+            <a:r>
+              <a:rPr sz="1400" b="1" i="0">
                 <a:solidFill>
                   <a:srgbClr val="1B263B"/>
                 </a:solidFill>
@@ -13032,7 +13153,7 @@
               <a:t>Error analysis: </a:t>
             </a:r>
             <a:r>
-              <a:rPr sz="1600" b="0" i="0">
+              <a:rPr sz="1400" b="0" i="0">
                 <a:solidFill>
                   <a:srgbClr val="1B263B"/>
                 </a:solidFill>
@@ -13040,33 +13161,6 @@
                 <a:cs typeface="Nirmala UI"/>
               </a:rPr>
               <a:t>largest confusion is true None predicted Favour (286): factual sentences with no opinion marker. Against recall 0.54.</a:t>
-            </a:r>
-          </a:p>
-          <a:p>
-            <a:pPr algn="l">
-              <a:spcAft>
-                <a:spcPts val="500"/>
-              </a:spcAft>
-            </a:pPr>
-            <a:r>
-              <a:rPr sz="1600" b="1" i="0">
-                <a:solidFill>
-                  <a:srgbClr val="E76F51"/>
-                </a:solidFill>
-                <a:latin typeface="Calibri"/>
-                <a:cs typeface="Nirmala UI"/>
-              </a:rPr>
-              <a:t>English to Indic pilot (dev only, synthetic): </a:t>
-            </a:r>
-            <a:r>
-              <a:rPr sz="1600" b="0" i="0">
-                <a:solidFill>
-                  <a:srgbClr val="1B263B"/>
-                </a:solidFill>
-                <a:latin typeface="Calibri"/>
-                <a:cs typeface="Nirmala UI"/>
-              </a:rPr>
-              <a:t>macro-F1 0.341, predicts None for 131 of 150; floor 0.167. Not comparable to official results.</a:t>
             </a:r>
           </a:p>
         </p:txBody>

</xml_diff>

<commit_message>
Add team members to README and deck
List Neya Tripathi, Aditya Goel and Kushika Mishra with enrolment numbers
alongside Sumukh Gupta in the README team section, the deck title slide
and every slide footer. Deck regenerated from src/make_deck.py.

Co-Authored-By: Claude Opus 5.5 <noreply@anthropic.com>
Claude-Session: https://claude.ai/code/session_01SkcFeCe9UUZNKJ47CDxu6X
</commit_message>
<xml_diff>
--- a/outputs/Milestone1_Sumukh_S24CSEU0570.pptx
+++ b/outputs/Milestone1_Sumukh_S24CSEU0570.pptx
@@ -4381,8 +4381,8 @@
         </p:nvSpPr>
         <p:spPr>
           <a:xfrm>
-            <a:off x="731520" y="4754880"/>
-            <a:ext cx="7315200" cy="1280160"/>
+            <a:off x="731520" y="4434840"/>
+            <a:ext cx="3291840" cy="2011680"/>
           </a:xfrm>
           <a:prstGeom prst="rect">
             <a:avLst/>
@@ -4417,7 +4417,7 @@
               </a:spcAft>
             </a:pPr>
             <a:r>
-              <a:rPr sz="2000" b="0" i="0">
+              <a:rPr sz="1700" b="0" i="0">
                 <a:solidFill>
                   <a:srgbClr val="FFFFFF"/>
                 </a:solidFill>
@@ -4434,13 +4434,103 @@
               </a:spcAft>
             </a:pPr>
             <a:r>
-              <a:rPr sz="2000" b="0" i="0">
+              <a:rPr sz="1700" b="0" i="0">
                 <a:solidFill>
                   <a:srgbClr val="FFFFFF"/>
                 </a:solidFill>
                 <a:latin typeface="Calibri"/>
                 <a:cs typeface="Nirmala UI"/>
               </a:rPr>
+              <a:t>Neya Tripathi  |  S24CSEU0609</a:t>
+            </a:r>
+          </a:p>
+          <a:p>
+            <a:pPr algn="l">
+              <a:spcAft>
+                <a:spcPts val="400"/>
+              </a:spcAft>
+            </a:pPr>
+            <a:r>
+              <a:rPr sz="1700" b="0" i="0">
+                <a:solidFill>
+                  <a:srgbClr val="FFFFFF"/>
+                </a:solidFill>
+                <a:latin typeface="Calibri"/>
+                <a:cs typeface="Nirmala UI"/>
+              </a:rPr>
+              <a:t>Aditya Goel  |  S24CSEU0614</a:t>
+            </a:r>
+          </a:p>
+          <a:p>
+            <a:pPr algn="l">
+              <a:spcAft>
+                <a:spcPts val="400"/>
+              </a:spcAft>
+            </a:pPr>
+            <a:r>
+              <a:rPr sz="1700" b="0" i="0">
+                <a:solidFill>
+                  <a:srgbClr val="FFFFFF"/>
+                </a:solidFill>
+                <a:latin typeface="Calibri"/>
+                <a:cs typeface="Nirmala UI"/>
+              </a:rPr>
+              <a:t>Kushika Mishra  |  S24CSEU0652</a:t>
+            </a:r>
+          </a:p>
+        </p:txBody>
+      </p:sp>
+      <p:sp>
+        <p:nvSpPr>
+          <p:cNvPr id="7" name="Rectangle 6"/>
+          <p:cNvSpPr/>
+          <p:nvPr/>
+        </p:nvSpPr>
+        <p:spPr>
+          <a:xfrm>
+            <a:off x="4297680" y="4434840"/>
+            <a:ext cx="3383280" cy="2011680"/>
+          </a:xfrm>
+          <a:prstGeom prst="rect">
+            <a:avLst/>
+          </a:prstGeom>
+          <a:noFill/>
+          <a:ln>
+            <a:noFill/>
+          </a:ln>
+          <a:effectLst/>
+        </p:spPr>
+        <p:style>
+          <a:lnRef idx="1">
+            <a:schemeClr val="accent1"/>
+          </a:lnRef>
+          <a:fillRef idx="3">
+            <a:schemeClr val="accent1"/>
+          </a:fillRef>
+          <a:effectRef idx="2">
+            <a:schemeClr val="accent1"/>
+          </a:effectRef>
+          <a:fontRef idx="minor">
+            <a:schemeClr val="lt1"/>
+          </a:fontRef>
+        </p:style>
+        <p:txBody>
+          <a:bodyPr rtlCol="0" anchor="t" wrap="square" lIns="0" rIns="0"/>
+          <a:lstStyle/>
+          <a:p>
+            <a:pPr algn="l">
+              <a:spcAft>
+                <a:spcPts val="400"/>
+              </a:spcAft>
+            </a:pPr>
+            <a:r>
+              <a:rPr sz="1700" b="0" i="0">
+                <a:solidFill>
+                  <a:srgbClr val="C9D3E3"/>
+                </a:solidFill>
+                <a:latin typeface="Calibri"/>
+                <a:cs typeface="Nirmala UI"/>
+              </a:rPr>
               <a:t>B.Tech CSE, Bennett University</a:t>
             </a:r>
           </a:p>
@@ -4451,9 +4541,9 @@
               </a:spcAft>
             </a:pPr>
             <a:r>
-              <a:rPr sz="2000" b="0" i="0">
-                <a:solidFill>
-                  <a:srgbClr val="FFFFFF"/>
+              <a:rPr sz="1700" b="0" i="0">
+                <a:solidFill>
+                  <a:srgbClr val="C9D3E3"/>
                 </a:solidFill>
                 <a:latin typeface="Calibri"/>
                 <a:cs typeface="Nirmala UI"/>
@@ -4465,7 +4555,7 @@
       </p:sp>
       <p:sp>
         <p:nvSpPr>
-          <p:cNvPr id="7" name="Rectangle 6"/>
+          <p:cNvPr id="8" name="Rectangle 7"/>
           <p:cNvSpPr/>
           <p:nvPr/>
         </p:nvSpPr>
@@ -4700,7 +4790,7 @@
                 <a:latin typeface="Calibri"/>
                 <a:cs typeface="Nirmala UI"/>
               </a:rPr>
-              <a:t>Sumukh Gupta  |  S24CSEU0570  |  CSET346 NLP  |  Milestone 1</a:t>
+              <a:t>Sumukh Gupta, Neya Tripathi, Aditya Goel, Kushika Mishra  |  CSET346 NLP  |  Milestone 1</a:t>
             </a:r>
           </a:p>
         </p:txBody>
@@ -5409,7 +5499,7 @@
                 <a:latin typeface="Calibri"/>
                 <a:cs typeface="Nirmala UI"/>
               </a:rPr>
-              <a:t>Sumukh Gupta  |  S24CSEU0570  |  CSET346 NLP  |  Milestone 1</a:t>
+              <a:t>Sumukh Gupta, Neya Tripathi, Aditya Goel, Kushika Mishra  |  CSET346 NLP  |  Milestone 1</a:t>
             </a:r>
           </a:p>
         </p:txBody>
@@ -6557,7 +6647,7 @@
                 <a:latin typeface="Calibri"/>
                 <a:cs typeface="Nirmala UI"/>
               </a:rPr>
-              <a:t>Sumukh Gupta  |  S24CSEU0570  |  CSET346 NLP  |  Milestone 1</a:t>
+              <a:t>Sumukh Gupta, Neya Tripathi, Aditya Goel, Kushika Mishra  |  CSET346 NLP  |  Milestone 1</a:t>
             </a:r>
           </a:p>
         </p:txBody>
@@ -7536,7 +7626,7 @@
                 <a:latin typeface="Calibri"/>
                 <a:cs typeface="Nirmala UI"/>
               </a:rPr>
-              <a:t>Sumukh Gupta  |  S24CSEU0570  |  CSET346 NLP  |  Milestone 1</a:t>
+              <a:t>Sumukh Gupta, Neya Tripathi, Aditya Goel, Kushika Mishra  |  CSET346 NLP  |  Milestone 1</a:t>
             </a:r>
           </a:p>
         </p:txBody>
@@ -8614,7 +8704,7 @@
                 <a:latin typeface="Calibri"/>
                 <a:cs typeface="Nirmala UI"/>
               </a:rPr>
-              <a:t>Sumukh Gupta  |  S24CSEU0570  |  CSET346 NLP  |  Milestone 1</a:t>
+              <a:t>Sumukh Gupta, Neya Tripathi, Aditya Goel, Kushika Mishra  |  CSET346 NLP  |  Milestone 1</a:t>
             </a:r>
           </a:p>
         </p:txBody>
@@ -10000,7 +10090,7 @@
                 <a:latin typeface="Calibri"/>
                 <a:cs typeface="Nirmala UI"/>
               </a:rPr>
-              <a:t>Sumukh Gupta  |  S24CSEU0570  |  CSET346 NLP  |  Milestone 1</a:t>
+              <a:t>Sumukh Gupta, Neya Tripathi, Aditya Goel, Kushika Mishra  |  CSET346 NLP  |  Milestone 1</a:t>
             </a:r>
           </a:p>
         </p:txBody>
@@ -10608,7 +10698,7 @@
                 <a:latin typeface="Calibri"/>
                 <a:cs typeface="Nirmala UI"/>
               </a:rPr>
-              <a:t>Sumukh Gupta  |  S24CSEU0570  |  CSET346 NLP  |  Milestone 1</a:t>
+              <a:t>Sumukh Gupta, Neya Tripathi, Aditya Goel, Kushika Mishra  |  CSET346 NLP  |  Milestone 1</a:t>
             </a:r>
           </a:p>
         </p:txBody>
@@ -12070,7 +12160,7 @@
                 <a:latin typeface="Calibri"/>
                 <a:cs typeface="Nirmala UI"/>
               </a:rPr>
-              <a:t>Sumukh Gupta  |  S24CSEU0570  |  CSET346 NLP  |  Milestone 1</a:t>
+              <a:t>Sumukh Gupta, Neya Tripathi, Aditya Goel, Kushika Mishra  |  CSET346 NLP  |  Milestone 1</a:t>
             </a:r>
           </a:p>
         </p:txBody>
@@ -12776,7 +12866,7 @@
                 <a:latin typeface="Calibri"/>
                 <a:cs typeface="Nirmala UI"/>
               </a:rPr>
-              <a:t>Sumukh Gupta  |  S24CSEU0570  |  CSET346 NLP  |  Milestone 1</a:t>
+              <a:t>Sumukh Gupta, Neya Tripathi, Aditya Goel, Kushika Mishra  |  CSET346 NLP  |  Milestone 1</a:t>
             </a:r>
           </a:p>
         </p:txBody>

</xml_diff>